<commit_message>
feat: power law rectangle decomposition on /I + on-chain multivariate + investigations 10-12
- Add /I route serving rotated-rectangle decomposition of price in log-log space
- Add tools/multivariate_onchain.py (fetches blockchain.com metrics, tests Metcalfe)
- Update FAQ 9.6 with investigations 10-12 (multivariate, phase-space, neural nets)
- Update research summary and PowerPoint (39 slides)

Co-Authored-By: Claude Opus 4.6 (1M context) <noreply@anthropic.com>
</commit_message>
<xml_diff>
--- a/bitcoin_decomposition.pptx
+++ b/bitcoin_decomposition.pptx
@@ -41,6 +41,9 @@
     <p:sldId id="289" r:id="rId40"/>
     <p:sldId id="290" r:id="rId41"/>
     <p:sldId id="291" r:id="rId42"/>
+    <p:sldId id="292" r:id="rId43"/>
+    <p:sldId id="293" r:id="rId44"/>
+    <p:sldId id="294" r:id="rId45"/>
   </p:sldIdLst>
   <p:sldSz cx="12191695" cy="6858000" type="screen4x3"/>
   <p:notesSz cx="6858000" cy="9144000"/>
@@ -12099,6 +12102,60 @@
 </p:sld>
 </file>
 
+<file path=ppt/slides/slide37.xml><?xml version="1.0" encoding="utf-8"?>
+<p:sld xmlns:a="http://schemas.openxmlformats.org/drawingml/2006/main" xmlns:p="http://schemas.openxmlformats.org/presentationml/2006/main" xmlns:r="http://schemas.openxmlformats.org/officeDocument/2006/relationships">
+  <p:cSld>
+    <p:spTree>
+      <p:nvGrpSpPr>
+        <p:cNvPr id="1" name=""/>
+        <p:cNvGrpSpPr/>
+        <p:nvPr/>
+      </p:nvGrpSpPr>
+      <p:grpSpPr/>
+    </p:spTree>
+  </p:cSld>
+  <p:clrMapOvr>
+    <a:masterClrMapping/>
+  </p:clrMapOvr>
+</p:sld>
+</file>
+
+<file path=ppt/slides/slide38.xml><?xml version="1.0" encoding="utf-8"?>
+<p:sld xmlns:a="http://schemas.openxmlformats.org/drawingml/2006/main" xmlns:p="http://schemas.openxmlformats.org/presentationml/2006/main" xmlns:r="http://schemas.openxmlformats.org/officeDocument/2006/relationships">
+  <p:cSld>
+    <p:spTree>
+      <p:nvGrpSpPr>
+        <p:cNvPr id="1" name=""/>
+        <p:cNvGrpSpPr/>
+        <p:nvPr/>
+      </p:nvGrpSpPr>
+      <p:grpSpPr/>
+    </p:spTree>
+  </p:cSld>
+  <p:clrMapOvr>
+    <a:masterClrMapping/>
+  </p:clrMapOvr>
+</p:sld>
+</file>
+
+<file path=ppt/slides/slide39.xml><?xml version="1.0" encoding="utf-8"?>
+<p:sld xmlns:a="http://schemas.openxmlformats.org/drawingml/2006/main" xmlns:p="http://schemas.openxmlformats.org/presentationml/2006/main" xmlns:r="http://schemas.openxmlformats.org/officeDocument/2006/relationships">
+  <p:cSld>
+    <p:spTree>
+      <p:nvGrpSpPr>
+        <p:cNvPr id="1" name=""/>
+        <p:cNvGrpSpPr/>
+        <p:nvPr/>
+      </p:nvGrpSpPr>
+      <p:grpSpPr/>
+    </p:spTree>
+  </p:cSld>
+  <p:clrMapOvr>
+    <a:masterClrMapping/>
+  </p:clrMapOvr>
+</p:sld>
+</file>
+
 <file path=ppt/slides/slide4.xml><?xml version="1.0" encoding="utf-8"?>
 <p:sld xmlns:a="http://schemas.openxmlformats.org/drawingml/2006/main" xmlns:p="http://schemas.openxmlformats.org/presentationml/2006/main" xmlns:r="http://schemas.openxmlformats.org/officeDocument/2006/relationships">
   <p:cSld>

</xml_diff>

<commit_message>
docs: practical example of why t=0 matters — same 100× gives β=1.9 to 9.5
FAQ 9.4: added table + 3-panel graph showing how the same $700→$70K price
increase implies wildly different slopes depending on genesis date choice.
PowerPoint: new slide 40 with the same example.

Co-Authored-By: Claude Opus 4.6 (1M context) <noreply@anthropic.com>
</commit_message>
<xml_diff>
--- a/bitcoin_decomposition.pptx
+++ b/bitcoin_decomposition.pptx
@@ -44,6 +44,7 @@
     <p:sldId id="292" r:id="rId43"/>
     <p:sldId id="293" r:id="rId44"/>
     <p:sldId id="294" r:id="rId45"/>
+    <p:sldId id="295" r:id="rId46"/>
   </p:sldIdLst>
   <p:sldSz cx="12191695" cy="6858000" type="screen4x3"/>
   <p:notesSz cx="6858000" cy="9144000"/>
@@ -12517,6 +12518,24 @@
 </p:sld>
 </file>
 
+<file path=ppt/slides/slide40.xml><?xml version="1.0" encoding="utf-8"?>
+<p:sld xmlns:a="http://schemas.openxmlformats.org/drawingml/2006/main" xmlns:p="http://schemas.openxmlformats.org/presentationml/2006/main" xmlns:r="http://schemas.openxmlformats.org/officeDocument/2006/relationships">
+  <p:cSld>
+    <p:spTree>
+      <p:nvGrpSpPr>
+        <p:cNvPr id="1" name=""/>
+        <p:cNvGrpSpPr/>
+        <p:nvPr/>
+      </p:nvGrpSpPr>
+      <p:grpSpPr/>
+    </p:spTree>
+  </p:cSld>
+  <p:clrMapOvr>
+    <a:masterClrMapping/>
+  </p:clrMapOvr>
+</p:sld>
+</file>
+
 <file path=ppt/slides/slide5.xml><?xml version="1.0" encoding="utf-8"?>
 <p:sld xmlns:a="http://schemas.openxmlformats.org/drawingml/2006/main" xmlns:p="http://schemas.openxmlformats.org/presentationml/2006/main" xmlns:r="http://schemas.openxmlformats.org/officeDocument/2006/relationships">
   <p:cSld>

</xml_diff>